<commit_message>
cde_creator v0.3.1: multi-standard CDE and PDE creation
Agent reads every standard governing the regulation, derives the union of
elements, and attaches all applicable standards per element in one create call.
Forced by fields being create-only: a standard cannot be attached afterwards,
so processing standards one at a time permanently precludes the others.

- policy rename: new_version -> full read -> PUT -> publish
- policy relink: re-point sources at a live policy (label, not derivation)
- deploy_tool: refuse to overwrite an Alation base tool on name collision
- Fetch CDE Overlay Standard Detail: the list carries no derived_requirements
</commit_message>
<xml_diff>
--- a/docs/aios-governance-flow.pptx
+++ b/docs/aios-governance-flow.pptx
@@ -1912,7 +1912,7 @@
           <p:nvPr/>
         </p:nvPicPr>
         <p:blipFill>
-          <a:blip r:embed="rId8"/>
+          <a:blip r:embed="rId6"/>
           <a:stretch>
             <a:fillRect/>
           </a:stretch>
@@ -2026,7 +2026,7 @@
                 <a:ea typeface="Inter Light" pitchFamily="34" charset="-122"/>
                 <a:cs typeface="Inter Light" pitchFamily="34" charset="-120"/>
               </a:rPr>
-              <a:t>Drafted from standards;</a:t>
+              <a:t>Agent drafts them and</a:t>
             </a:r>
             <a:endParaRPr lang="en-US" sz="800" dirty="0"/>
           </a:p>
@@ -2046,7 +2046,7 @@
                 <a:ea typeface="Inter Light" pitchFamily="34" charset="-122"/>
                 <a:cs typeface="Inter Light" pitchFamily="34" charset="-120"/>
               </a:rPr>
-              <a:t>CDM discovers the</a:t>
+              <a:t>finds the columns; a</a:t>
             </a:r>
             <a:endParaRPr lang="en-US" sz="800" dirty="0"/>
           </a:p>
@@ -2066,7 +2066,7 @@
                 <a:ea typeface="Inter Light" pitchFamily="34" charset="-122"/>
                 <a:cs typeface="Inter Light" pitchFamily="34" charset="-120"/>
               </a:rPr>
-              <a:t>physical columns</a:t>
+              <a:t>steward accepts</a:t>
             </a:r>
             <a:endParaRPr lang="en-US" sz="800" dirty="0"/>
           </a:p>
@@ -2099,13 +2099,13 @@
             <a:r>
               <a:rPr lang="en-US" sz="650" b="1" dirty="0">
                 <a:solidFill>
-                  <a:srgbClr val="FF9900"/>
+                  <a:srgbClr val="80DED8"/>
                 </a:solidFill>
                 <a:latin typeface="Inter SemiBold" pitchFamily="34" charset="0"/>
                 <a:ea typeface="Inter SemiBold" pitchFamily="34" charset="-122"/>
                 <a:cs typeface="Inter SemiBold" pitchFamily="34" charset="-120"/>
               </a:rPr>
-              <a:t>PARTIAL</a:t>
+              <a:t>BUILT</a:t>
             </a:r>
             <a:endParaRPr lang="en-US" sz="650" dirty="0"/>
           </a:p>

</xml_diff>